<commit_message>
EcoLoop Building Agents: verified closed-loop building control
Autonomous supervisory control of a live EnergyPlus 26.1.0 simulation by a
local open-weight model (qwen3:8b via Ollama) over genuine MCP stdio tools,
with an independent deterministic safety layer holding final authority on
every actuator write.

Verified evidence: physical actuator applications with immutable provenance,
digit-identical schedule replay of both retained agent runs, strict baseline
compatibility gating, real EPW-backed forecast context, per-run process
isolation for concurrent simulations, and a dark operations dashboard that
reads only the durable run store and fails closed without verified evidence.

Measured one-day operating points against a shared baseline: comfort-max
(+9.53% electricity, compliance 69.62% -> 90.38%) and energy-lean (+2.09%,
69.62% -> 81.92%). Reported as measured trade-offs, never as savings claims.

Owner: Krishnaa Nair
</commit_message>
<xml_diff>
--- a/presentation/ecoloop-submission.pptx
+++ b/presentation/ecoloop-submission.pptx
@@ -13,6 +13,7 @@
     <p:sldId id="258" r:id="rId4"/>
     <p:sldId id="259" r:id="rId5"/>
     <p:sldId id="260" r:id="rId6"/>
+    <p:sldId id="262" r:id="rId13"/>
     <p:sldId id="261" r:id="rId7"/>
   </p:sldIdLst>
   <p:sldSz cx="12192000" cy="6858000"/>
@@ -1026,6 +1027,101 @@
             <a:endParaRPr/>
           </a:p>
         </p:txBody>
+      </p:sp>
+    </p:spTree>
+  </p:cSld>
+  <p:clrMapOvr>
+    <a:masterClrMapping/>
+  </p:clrMapOvr>
+</p:notes>
+</file>
+
+<file path=ppt/notesSlides/notesSlide7.xml><?xml version="1.0" encoding="utf-8"?>
+<p:notes xmlns:a="http://schemas.openxmlformats.org/drawingml/2006/main" xmlns:p="http://schemas.openxmlformats.org/presentationml/2006/main" xmlns:r="http://schemas.openxmlformats.org/officeDocument/2006/relationships">
+  <p:cSld>
+    <p:spTree>
+      <p:nvGrpSpPr>
+        <p:cNvPr id="1" name=""/>
+        <p:cNvGrpSpPr/>
+        <p:nvPr/>
+      </p:nvGrpSpPr>
+      <p:grpSpPr>
+        <a:xfrm>
+          <a:off x="0" y="0"/>
+          <a:ext cx="0" cy="0"/>
+          <a:chOff x="0" y="0"/>
+          <a:chExt cx="0" cy="0"/>
+        </a:xfrm>
+      </p:grpSpPr>
+      <p:sp>
+        <p:nvSpPr>
+          <p:cNvPr id="2" name="Slide Image Placeholder 1"/>
+          <p:cNvSpPr>
+            <a:spLocks noGrp="1"/>
+          </p:cNvSpPr>
+          <p:nvPr>
+            <p:ph type="sldImg" idx="2"/>
+          </p:nvPr>
+        </p:nvSpPr>
+        <p:spPr/>
+      </p:sp>
+      <p:sp>
+        <p:nvSpPr>
+          <p:cNvPr id="3" name="Notes Placeholder 2"/>
+          <p:cNvSpPr>
+            <a:spLocks noGrp="1"/>
+          </p:cNvSpPr>
+          <p:nvPr>
+            <p:ph type="body" idx="3" sz="quarter"/>
+          </p:nvPr>
+        </p:nvSpPr>
+        <p:spPr/>
+        <p:txBody>
+          <a:bodyPr/>
+          <a:lstStyle/>
+          <a:p>
+            <a:r>
+              <a:t>[Sources]</a:t>
+            </a:r>
+          </a:p>
+          <a:p>
+            <a:r>
+              <a:t>- Comfort-max pair: baseline-20260726T151534Z-df519672 / agent-20260726T151601Z-4f076a27 (runs/agent-.../export/comparison.json)</a:t>
+            </a:r>
+          </a:p>
+          <a:p>
+            <a:r>
+              <a:t>- Energy-lean pair: baseline-20260726T180508Z-48166652 / agent-20260726T180544Z-ea3913ad (verified comparison, 2026-07-26)</a:t>
+            </a:r>
+          </a:p>
+          <a:p>
+            <a:r>
+              <a:t>- Replay proofs: replay-20260726T165649Z-6ff9f492, replay-20260726T171617Z-5ffa3497 (metrics digit-identical to sources)</a:t>
+            </a:r>
+          </a:p>
+          <a:p>
+            <a:r>
+              <a:t>- Electricity change = 100 * (agent - baseline) / baseline; compliance from occupied zone telemetry (22-26 C operative)</a:t>
+            </a:r>
+          </a:p>
+          <a:p>
+            <a:r>
+              <a:t>- Full validation record: docs/audit/FINAL_TEST_REPORT.md and docs/audit/INDEPENDENT_FINAL_AUDIT.md</a:t>
+            </a:r>
+          </a:p>
+        </p:txBody>
+      </p:sp>
+      <p:sp>
+        <p:nvSpPr>
+          <p:cNvPr id="4" name="Slide Number Placeholder 3"/>
+          <p:cNvSpPr>
+            <a:spLocks noGrp="1"/>
+          </p:cNvSpPr>
+          <p:nvPr>
+            <p:ph type="sldNum" idx="5" sz="quarter"/>
+          </p:nvPr>
+        </p:nvSpPr>
+        <p:spPr/>
       </p:sp>
     </p:spTree>
   </p:cSld>
@@ -5184,7 +5280,7 @@
                 <a:ea typeface="Arial"/>
                 <a:cs typeface="Arial"/>
               </a:rPr>
-              <a:t>Team: EcoLoop</a:t>
+              <a:t>Team: Krishnaa Nair — EcoLoop</a:t>
             </a:r>
           </a:p>
           <a:p>
@@ -5675,6 +5771,30 @@
           </a:p>
         </p:txBody>
       </p:sp>
+      <p:pic>
+        <p:nvPicPr>
+          <p:cNvPr id="17411" name="Picture 17410" descr="chart_evidence.png"/>
+          <p:cNvPicPr>
+            <a:picLocks noChangeAspect="1"/>
+          </p:cNvPicPr>
+          <p:nvPr/>
+        </p:nvPicPr>
+        <p:blipFill>
+          <a:blip r:embed="rId3"/>
+          <a:stretch>
+            <a:fillRect/>
+          </a:stretch>
+        </p:blipFill>
+        <p:spPr>
+          <a:xfrm>
+            <a:off x="2258568" y="3310128"/>
+            <a:ext cx="7680960" cy="3584448"/>
+          </a:xfrm>
+          <a:prstGeom prst="rect">
+            <a:avLst/>
+          </a:prstGeom>
+        </p:spPr>
+      </p:pic>
     </p:spTree>
     <p:extLst>
       <p:ext uri="{BB962C8B-B14F-4D97-AF65-F5344CB8AC3E}">
@@ -6271,6 +6391,30 @@
           </a:p>
         </p:txBody>
       </p:sp>
+      <p:pic>
+        <p:nvPicPr>
+          <p:cNvPr id="17411" name="Picture 17410" descr="chart_week_energy.png"/>
+          <p:cNvPicPr>
+            <a:picLocks noChangeAspect="1"/>
+          </p:cNvPicPr>
+          <p:nvPr/>
+        </p:nvPicPr>
+        <p:blipFill>
+          <a:blip r:embed="rId3"/>
+          <a:stretch>
+            <a:fillRect/>
+          </a:stretch>
+        </p:blipFill>
+        <p:spPr>
+          <a:xfrm>
+            <a:off x="2788920" y="3611880"/>
+            <a:ext cx="6583680" cy="3218688"/>
+          </a:xfrm>
+          <a:prstGeom prst="rect">
+            <a:avLst/>
+          </a:prstGeom>
+        </p:spPr>
+      </p:pic>
     </p:spTree>
     <p:extLst>
       <p:ext uri="{BB962C8B-B14F-4D97-AF65-F5344CB8AC3E}">
@@ -6306,6 +6450,339 @@
           <p:cNvPr id="17409" name="Title 1">
             <a:extLst>
               <a:ext uri="{FF2B5EF4-FFF2-40B4-BE49-F238E27FC236}">
+                <a16:creationId xmlns:a16="http://schemas.microsoft.com/office/drawing/2014/main" id="{5E03BF1A-7989-5C44-934B-D93E149184A6}"/>
+              </a:ext>
+            </a:extLst>
+          </p:cNvPr>
+          <p:cNvSpPr>
+            <a:spLocks noGrp="1"/>
+          </p:cNvSpPr>
+          <p:nvPr>
+            <p:ph type="title"/>
+          </p:nvPr>
+        </p:nvSpPr>
+        <p:spPr/>
+        <p:txBody>
+          <a:bodyPr/>
+          <a:lstStyle/>
+          <a:p>
+            <a:pPr>
+              <a:buNone/>
+            </a:pPr>
+            <a:r>
+              <a:rPr sz="3600" b="1">
+                <a:latin typeface="Times New Roman"/>
+                <a:ea typeface="Times New Roman"/>
+                <a:cs typeface="Times New Roman"/>
+              </a:rPr>
+              <a:t>THE MEASURED COMFORT/ENERGY DIAL</a:t>
+            </a:r>
+          </a:p>
+        </p:txBody>
+      </p:sp>
+      <p:sp>
+        <p:nvSpPr>
+          <p:cNvPr id="17410" name="TextBox 8">
+            <a:extLst>
+              <a:ext uri="{FF2B5EF4-FFF2-40B4-BE49-F238E27FC236}">
+                <a16:creationId xmlns:a16="http://schemas.microsoft.com/office/drawing/2014/main" id="{DD0C6F84-D6ED-416D-7179-055149D83FA6}"/>
+              </a:ext>
+            </a:extLst>
+          </p:cNvPr>
+          <p:cNvSpPr>
+            <a:spLocks noGrp="1"/>
+          </p:cNvSpPr>
+          <p:nvPr/>
+        </p:nvSpPr>
+        <p:spPr>
+          <a:xfrm>
+            <a:off x="609600" y="2533653"/>
+            <a:ext cx="9385300" cy="3078480"/>
+          </a:xfrm>
+          <a:prstGeom prst="rect">
+            <a:avLst/>
+          </a:prstGeom>
+          <a:noFill/>
+          <a:ln w="9525">
+            <a:noFill/>
+          </a:ln>
+        </p:spPr>
+        <p:txBody>
+          <a:bodyPr wrap="square">
+            <a:spAutoFit/>
+          </a:bodyPr>
+          <a:lstStyle/>
+          <a:p>
+            <a:pPr marL="36" indent="-36">
+              <a:spcBef>
+                <a:spcPts val="0"/>
+              </a:spcBef>
+              <a:spcAft>
+                <a:spcPts val="0"/>
+              </a:spcAft>
+              <a:buChar char="•"/>
+            </a:pPr>
+            <a:r>
+              <a:rPr sz="2800">
+                <a:solidFill>
+                  <a:srgbClr val="000000"/>
+                </a:solidFill>
+                <a:latin typeface="Arial"/>
+                <a:ea typeface="Arial"/>
+                <a:cs typeface="Arial"/>
+              </a:rPr>
+              <a:t>Two verified one-day operating points, one policy dial:</a:t>
+            </a:r>
+          </a:p>
+          <a:p>
+            <a:pPr marL="36" indent="-36">
+              <a:spcBef>
+                <a:spcPts val="0"/>
+              </a:spcBef>
+              <a:spcAft>
+                <a:spcPts val="0"/>
+              </a:spcAft>
+              <a:buChar char="•"/>
+            </a:pPr>
+            <a:r>
+              <a:rPr sz="2800">
+                <a:solidFill>
+                  <a:srgbClr val="000000"/>
+                </a:solidFill>
+                <a:latin typeface="Arial"/>
+                <a:ea typeface="Arial"/>
+                <a:cs typeface="Arial"/>
+              </a:rPr>
+              <a:t>Comfort-max: +9.53% kWh, compliance 69.6% → 90.4% (violations third).</a:t>
+            </a:r>
+          </a:p>
+          <a:p>
+            <a:pPr marL="36" indent="-36">
+              <a:spcBef>
+                <a:spcPts val="0"/>
+              </a:spcBef>
+              <a:spcAft>
+                <a:spcPts val="0"/>
+              </a:spcAft>
+              <a:buChar char="•"/>
+            </a:pPr>
+            <a:r>
+              <a:rPr sz="2800">
+                <a:solidFill>
+                  <a:srgbClr val="000000"/>
+                </a:solidFill>
+                <a:latin typeface="Arial"/>
+                <a:ea typeface="Arial"/>
+                <a:cs typeface="Arial"/>
+              </a:rPr>
+              <a:t>Energy-lean: +2.09% kWh, compliance 69.6% → 81.9%, zero fallbacks.</a:t>
+            </a:r>
+          </a:p>
+          <a:p>
+            <a:pPr marL="36" indent="-36">
+              <a:spcBef>
+                <a:spcPts val="0"/>
+              </a:spcBef>
+              <a:spcAft>
+                <a:spcPts val="0"/>
+              </a:spcAft>
+              <a:buChar char="•"/>
+            </a:pPr>
+            <a:r>
+              <a:rPr sz="2800">
+                <a:solidFill>
+                  <a:srgbClr val="000000"/>
+                </a:solidFill>
+                <a:latin typeface="Arial"/>
+                <a:ea typeface="Arial"/>
+                <a:cs typeface="Arial"/>
+              </a:rPr>
+              <a:t>Replays reproduce both retained runs digit-for-digit (170/170 actions).</a:t>
+            </a:r>
+          </a:p>
+        </p:txBody>
+      </p:sp>
+      <p:sp>
+        <p:nvSpPr>
+          <p:cNvPr id="6" name="Slide Number Placeholder 5">
+            <a:extLst>
+              <a:ext uri="{FF2B5EF4-FFF2-40B4-BE49-F238E27FC236}">
+                <a16:creationId xmlns:a16="http://schemas.microsoft.com/office/drawing/2014/main" id="{84B14AAA-63FC-5F17-FE74-5405495A1CD3}"/>
+              </a:ext>
+            </a:extLst>
+          </p:cNvPr>
+          <p:cNvSpPr>
+            <a:spLocks noGrp="1"/>
+          </p:cNvSpPr>
+          <p:nvPr>
+            <p:ph type="sldNum" idx="12"/>
+          </p:nvPr>
+        </p:nvSpPr>
+        <p:spPr/>
+        <p:txBody>
+          <a:bodyPr/>
+          <a:lstStyle/>
+          <a:p>
+            <a:pPr marL="0" marR="0" lvl="0" indent="0" algn="r" defTabSz="457200">
+              <a:lnSpc>
+                <a:spcPct val="100000"/>
+              </a:lnSpc>
+              <a:spcBef>
+                <a:spcPct val="0"/>
+              </a:spcBef>
+              <a:spcAft>
+                <a:spcPct val="0"/>
+              </a:spcAft>
+              <a:buClrTx/>
+              <a:buSzTx/>
+              <a:buFontTx/>
+              <a:buNone/>
+            </a:pPr>
+            <a:fld id="{EE5B3003-2C54-13C6-9832-7637201064DE}" type="slidenum">
+              <a:rPr sz="1200" b="1" i="0" u="none" cap="none">
+                <a:ln>
+                  <a:noFill/>
+                </a:ln>
+                <a:solidFill>
+                  <a:prstClr val="white"/>
+                </a:solidFill>
+                <a:latin typeface="TradeGothic"/>
+                <a:ea typeface="TradeGothic"/>
+                <a:cs typeface="TradeGothic"/>
+              </a:rPr>
+              <a:t>5</a:t>
+            </a:fld>
+            <a:endParaRPr sz="1200" b="1" i="0" u="none" cap="none">
+              <a:ln>
+                <a:noFill/>
+              </a:ln>
+              <a:solidFill>
+                <a:prstClr val="white"/>
+              </a:solidFill>
+              <a:latin typeface="TradeGothic"/>
+              <a:ea typeface="TradeGothic"/>
+              <a:cs typeface="TradeGothic"/>
+            </a:endParaRPr>
+          </a:p>
+        </p:txBody>
+      </p:sp>
+      <p:sp>
+        <p:nvSpPr>
+          <p:cNvPr id="7" name="Footer Placeholder 6">
+            <a:extLst>
+              <a:ext uri="{FF2B5EF4-FFF2-40B4-BE49-F238E27FC236}">
+                <a16:creationId xmlns:a16="http://schemas.microsoft.com/office/drawing/2014/main" id="{34C6332B-BBD9-799D-50C5-6A19BC85E43E}"/>
+              </a:ext>
+            </a:extLst>
+          </p:cNvPr>
+          <p:cNvSpPr>
+            <a:spLocks noGrp="1"/>
+          </p:cNvSpPr>
+          <p:nvPr>
+            <p:ph type="ftr" idx="11"/>
+          </p:nvPr>
+        </p:nvSpPr>
+        <p:spPr>
+          <a:xfrm>
+            <a:off x="4648200" y="6356353"/>
+            <a:ext cx="3204000" cy="365125"/>
+          </a:xfrm>
+        </p:spPr>
+        <p:txBody>
+          <a:bodyPr/>
+          <a:lstStyle/>
+          <a:p>
+            <a:pPr marL="0" marR="0" lvl="0" indent="0" algn="ctr" defTabSz="457200">
+              <a:lnSpc>
+                <a:spcPct val="100000"/>
+              </a:lnSpc>
+              <a:spcBef>
+                <a:spcPts val="0"/>
+              </a:spcBef>
+              <a:spcAft>
+                <a:spcPts val="0"/>
+              </a:spcAft>
+              <a:buClrTx/>
+              <a:buSzTx/>
+              <a:buFontTx/>
+              <a:buNone/>
+            </a:pPr>
+            <a:r>
+              <a:rPr sz="1200" b="0" i="0" u="none" cap="none">
+                <a:ln>
+                  <a:noFill/>
+                </a:ln>
+                <a:solidFill>
+                  <a:prstClr val="white"/>
+                </a:solidFill>
+                <a:latin typeface="TradeGothic"/>
+                <a:ea typeface="TradeGothic"/>
+                <a:cs typeface="TradeGothic"/>
+              </a:rPr>
+              <a:t>EcoLoop | Building Agents</a:t>
+            </a:r>
+          </a:p>
+        </p:txBody>
+      </p:sp>
+      <p:pic>
+        <p:nvPicPr>
+          <p:cNvPr id="17411" name="Picture 17410" descr="chart_dial.png"/>
+          <p:cNvPicPr>
+            <a:picLocks noChangeAspect="1"/>
+          </p:cNvPicPr>
+          <p:nvPr/>
+        </p:nvPicPr>
+        <p:blipFill>
+          <a:blip r:embed="rId2"/>
+          <a:stretch>
+            <a:fillRect/>
+          </a:stretch>
+        </p:blipFill>
+        <p:spPr>
+          <a:xfrm>
+            <a:off x="2788920" y="3611880"/>
+            <a:ext cx="6583680" cy="3218688"/>
+          </a:xfrm>
+          <a:prstGeom prst="rect">
+            <a:avLst/>
+          </a:prstGeom>
+        </p:spPr>
+      </p:pic>
+    </p:spTree>
+    <p:extLst>
+      <p:ext uri="{BB962C8B-B14F-4D97-AF65-F5344CB8AC3E}">
+        <p14:creationId xmlns:p14="http://schemas.microsoft.com/office/powerpoint/2010/main" val="973447886"/>
+      </p:ext>
+    </p:extLst>
+  </p:cSld>
+  <p:clrMapOvr>
+    <a:masterClrMapping/>
+  </p:clrMapOvr>
+</p:sld>
+</file>
+
+<file path=ppt/slides/slide7.xml><?xml version="1.0" encoding="utf-8"?>
+<p:sld xmlns:a="http://schemas.openxmlformats.org/drawingml/2006/main" xmlns:r="http://schemas.openxmlformats.org/officeDocument/2006/relationships" xmlns:p="http://schemas.openxmlformats.org/presentationml/2006/main">
+  <p:cSld>
+    <p:spTree>
+      <p:nvGrpSpPr>
+        <p:cNvPr id="1" name=""/>
+        <p:cNvGrpSpPr/>
+        <p:nvPr/>
+      </p:nvGrpSpPr>
+      <p:grpSpPr>
+        <a:xfrm>
+          <a:off x="0" y="0"/>
+          <a:ext cx="0" cy="0"/>
+          <a:chOff x="0" y="0"/>
+          <a:chExt cx="0" cy="0"/>
+        </a:xfrm>
+      </p:grpSpPr>
+      <p:sp>
+        <p:nvSpPr>
+          <p:cNvPr id="17409" name="Title 1">
+            <a:extLst>
+              <a:ext uri="{FF2B5EF4-FFF2-40B4-BE49-F238E27FC236}">
                 <a16:creationId xmlns:a16="http://schemas.microsoft.com/office/drawing/2014/main" id="{FBB70433-AF71-4830-95A8-CB25B24F9A2C}"/>
               </a:ext>
             </a:extLst>
@@ -6431,7 +6908,7 @@
                 <a:ea typeface="Arial"/>
                 <a:cs typeface="Arial"/>
               </a:rPr>
-              <a:t> Next: reduce measured energy use without losing comfort, then commission a BACnet/MQTT adapter with site-level safeties.</a:t>
+              <a:t> Next: push the measured dial below baseline energy at the comfort boundary, then commission a BACnet/MQTT adapter with site-level safeties.</a:t>
             </a:r>
           </a:p>
         </p:txBody>

</xml_diff>